<commit_message>
docs: remove documentation process notes
</commit_message>
<xml_diff>
--- a/docs/DVLD-System-Overview.pptx
+++ b/docs/DVLD-System-Overview.pptx
@@ -3846,7 +3846,7 @@
                 </a:solidFill>
                 <a:latin typeface="Calibri"/>
               </a:rPr>
-              <a:t>•  Scope</a:t>
+              <a:t>•  Scope  — Training / portfolio project — no automated tests or CI</a:t>
             </a:r>
             <a:r>
               <a:rPr sz="1700">
@@ -3855,7 +3855,7 @@
                 </a:solidFill>
                 <a:latin typeface="Calibri"/>
               </a:rPr>
-              <a:t>  — Training / portfolio project — no automated tests, no CI, nothing in this deck was executed</a:t>
+              <a:t/>
             </a:r>
           </a:p>
           <a:p>
@@ -3915,7 +3915,7 @@
                 </a:solidFill>
                 <a:latin typeface="Calibri"/>
               </a:rPr>
-              <a:t>DVLD — Driver &amp; Vehicle License Department  |  Training / portfolio project (source-derived, not executed)</a:t>
+              <a:t>DVLD — Driver &amp; Vehicle License Department  |  Training / portfolio project</a:t>
             </a:r>
           </a:p>
         </p:txBody>
@@ -4836,7 +4836,7 @@
                 </a:solidFill>
                 <a:latin typeface="Calibri"/>
               </a:rPr>
-              <a:t>DVLD — Driver &amp; Vehicle License Department  |  Training / portfolio project (source-derived, not executed)</a:t>
+              <a:t>DVLD — Driver &amp; Vehicle License Department  |  Training / portfolio project</a:t>
             </a:r>
           </a:p>
         </p:txBody>
@@ -5994,7 +5994,7 @@
                 </a:solidFill>
                 <a:latin typeface="Calibri"/>
               </a:rPr>
-              <a:t>DVLD — Driver &amp; Vehicle License Department  |  Training / portfolio project (source-derived, not executed)</a:t>
+              <a:t>DVLD — Driver &amp; Vehicle License Department  |  Training / portfolio project</a:t>
             </a:r>
           </a:p>
         </p:txBody>
@@ -7251,7 +7251,7 @@
                 </a:solidFill>
                 <a:latin typeface="Calibri"/>
               </a:rPr>
-              <a:t>DVLD — Driver &amp; Vehicle License Department  |  Training / portfolio project (source-derived, not executed)</a:t>
+              <a:t>DVLD — Driver &amp; Vehicle License Department  |  Training / portfolio project</a:t>
             </a:r>
           </a:p>
         </p:txBody>
@@ -7427,7 +7427,7 @@
                 </a:solidFill>
                 <a:latin typeface="Calibri"/>
               </a:rPr>
-              <a:t>Feature Map (source evidence)</a:t>
+              <a:t>Feature Map</a:t>
             </a:r>
           </a:p>
         </p:txBody>
@@ -8193,7 +8193,7 @@
                 </a:solidFill>
                 <a:latin typeface="Calibri"/>
               </a:rPr>
-              <a:t>DVLD — Driver &amp; Vehicle License Department  |  Training / portfolio project (source-derived, not executed)</a:t>
+              <a:t>DVLD — Driver &amp; Vehicle License Department  |  Training / portfolio project</a:t>
             </a:r>
           </a:p>
         </p:txBody>
@@ -8518,7 +8518,7 @@
                 </a:solidFill>
                 <a:latin typeface="Calibri"/>
               </a:rPr>
-              <a:t>•  Schema source</a:t>
+              <a:t>•  Database backup  — DVLD.bak is included; inspect its contents before restoring</a:t>
             </a:r>
             <a:r>
               <a:rPr sz="1700">
@@ -8527,7 +8527,7 @@
                 </a:solidFill>
                 <a:latin typeface="Calibri"/>
               </a:rPr>
-              <a:t>  — DVLD.bak — a SQL Server backup shipped in the repo; its contents have NOT been reviewed or verified</a:t>
+              <a:t/>
             </a:r>
           </a:p>
           <a:p>
@@ -8668,7 +8668,7 @@
                 </a:solidFill>
                 <a:latin typeface="Calibri"/>
               </a:rPr>
-              <a:t>DVLD — Driver &amp; Vehicle License Department  |  Training / portfolio project (source-derived, not executed)</a:t>
+              <a:t>DVLD — Driver &amp; Vehicle License Department  |  Training / portfolio project</a:t>
             </a:r>
           </a:p>
         </p:txBody>
@@ -9449,7 +9449,7 @@
                 </a:solidFill>
                 <a:latin typeface="Calibri"/>
               </a:rPr>
-              <a:t>Not verified in preparing this material: the app was not built or run. Follow these steps as guidance, not as a tested procedure.</a:t>
+              <a:t/>
             </a:r>
           </a:p>
         </p:txBody>
@@ -9484,7 +9484,7 @@
                 </a:solidFill>
                 <a:latin typeface="Calibri"/>
               </a:rPr>
-              <a:t>DVLD — Driver &amp; Vehicle License Department  |  Training / portfolio project (source-derived, not executed)</a:t>
+              <a:t>DVLD — Driver &amp; Vehicle License Department  |  Training / portfolio project</a:t>
             </a:r>
           </a:p>
         </p:txBody>
@@ -9734,7 +9734,7 @@
                 </a:solidFill>
                 <a:latin typeface="Calibri"/>
               </a:rPr>
-              <a:t>•  Not executed / not tested</a:t>
+              <a:t>•  Testing  — no automated test suite is included in the repository</a:t>
             </a:r>
             <a:r>
               <a:rPr sz="1700">
@@ -9743,7 +9743,7 @@
                 </a:solidFill>
                 <a:latin typeface="Calibri"/>
               </a:rPr>
-              <a:t>  — no build, run, or automated tests were performed for this documentation; no test suite exists in the repo</a:t>
+              <a:t/>
             </a:r>
           </a:p>
           <a:p>
@@ -9903,7 +9903,7 @@
                 </a:solidFill>
                 <a:latin typeface="Calibri"/>
               </a:rPr>
-              <a:t>DVLD — Driver &amp; Vehicle License Department  |  Training / portfolio project (source-derived, not executed)</a:t>
+              <a:t>DVLD — Driver &amp; Vehicle License Department  |  Training / portfolio project</a:t>
             </a:r>
           </a:p>
         </p:txBody>

</xml_diff>